<commit_message>
Sent follow up emails to companies that did not respond. Updated tracker
</commit_message>
<xml_diff>
--- a/docs/decks/business-case-deck/output/AgentScore-Business-Case-Native.pptx
+++ b/docs/decks/business-case-deck/output/AgentScore-Business-Case-Native.pptx
@@ -112,6 +112,11 @@
       </a:defRPr>
     </a:lvl9pPr>
   </p:defaultTextStyle>
+  <p:extLst>
+    <p:ext uri="{EFAFB233-063F-42B5-8137-9DF3F51BA10A}">
+      <p15:sldGuideLst xmlns:p15="http://schemas.microsoft.com/office/powerpoint/2012/main"/>
+    </p:ext>
+  </p:extLst>
 </p:presentation>
 </file>
 
@@ -262,7 +267,7 @@
           <a:p>
             <a:fld id="{17B77B90-EC0E-BC4E-91B7-09E65585EB38}" type="datetimeFigureOut">
               <a:rPr lang="en-US" smtClean="0"/>
-              <a:t>9/22/26</a:t>
+              <a:t>9/23/26</a:t>
             </a:fld>
             <a:endParaRPr lang="en-US"/>
           </a:p>
@@ -460,7 +465,7 @@
           <a:p>
             <a:fld id="{17B77B90-EC0E-BC4E-91B7-09E65585EB38}" type="datetimeFigureOut">
               <a:rPr lang="en-US" smtClean="0"/>
-              <a:t>9/22/26</a:t>
+              <a:t>9/23/26</a:t>
             </a:fld>
             <a:endParaRPr lang="en-US"/>
           </a:p>
@@ -668,7 +673,7 @@
           <a:p>
             <a:fld id="{17B77B90-EC0E-BC4E-91B7-09E65585EB38}" type="datetimeFigureOut">
               <a:rPr lang="en-US" smtClean="0"/>
-              <a:t>9/22/26</a:t>
+              <a:t>9/23/26</a:t>
             </a:fld>
             <a:endParaRPr lang="en-US"/>
           </a:p>
@@ -866,7 +871,7 @@
           <a:p>
             <a:fld id="{17B77B90-EC0E-BC4E-91B7-09E65585EB38}" type="datetimeFigureOut">
               <a:rPr lang="en-US" smtClean="0"/>
-              <a:t>9/22/26</a:t>
+              <a:t>9/23/26</a:t>
             </a:fld>
             <a:endParaRPr lang="en-US"/>
           </a:p>
@@ -1141,7 +1146,7 @@
           <a:p>
             <a:fld id="{17B77B90-EC0E-BC4E-91B7-09E65585EB38}" type="datetimeFigureOut">
               <a:rPr lang="en-US" smtClean="0"/>
-              <a:t>9/22/26</a:t>
+              <a:t>9/23/26</a:t>
             </a:fld>
             <a:endParaRPr lang="en-US"/>
           </a:p>
@@ -1406,7 +1411,7 @@
           <a:p>
             <a:fld id="{17B77B90-EC0E-BC4E-91B7-09E65585EB38}" type="datetimeFigureOut">
               <a:rPr lang="en-US" smtClean="0"/>
-              <a:t>9/22/26</a:t>
+              <a:t>9/23/26</a:t>
             </a:fld>
             <a:endParaRPr lang="en-US"/>
           </a:p>
@@ -1818,7 +1823,7 @@
           <a:p>
             <a:fld id="{17B77B90-EC0E-BC4E-91B7-09E65585EB38}" type="datetimeFigureOut">
               <a:rPr lang="en-US" smtClean="0"/>
-              <a:t>9/22/26</a:t>
+              <a:t>9/23/26</a:t>
             </a:fld>
             <a:endParaRPr lang="en-US"/>
           </a:p>
@@ -1959,7 +1964,7 @@
           <a:p>
             <a:fld id="{17B77B90-EC0E-BC4E-91B7-09E65585EB38}" type="datetimeFigureOut">
               <a:rPr lang="en-US" smtClean="0"/>
-              <a:t>9/22/26</a:t>
+              <a:t>9/23/26</a:t>
             </a:fld>
             <a:endParaRPr lang="en-US"/>
           </a:p>
@@ -2072,7 +2077,7 @@
           <a:p>
             <a:fld id="{17B77B90-EC0E-BC4E-91B7-09E65585EB38}" type="datetimeFigureOut">
               <a:rPr lang="en-US" smtClean="0"/>
-              <a:t>9/22/26</a:t>
+              <a:t>9/23/26</a:t>
             </a:fld>
             <a:endParaRPr lang="en-US"/>
           </a:p>
@@ -2383,7 +2388,7 @@
           <a:p>
             <a:fld id="{17B77B90-EC0E-BC4E-91B7-09E65585EB38}" type="datetimeFigureOut">
               <a:rPr lang="en-US" smtClean="0"/>
-              <a:t>9/22/26</a:t>
+              <a:t>9/23/26</a:t>
             </a:fld>
             <a:endParaRPr lang="en-US"/>
           </a:p>
@@ -2671,7 +2676,7 @@
           <a:p>
             <a:fld id="{17B77B90-EC0E-BC4E-91B7-09E65585EB38}" type="datetimeFigureOut">
               <a:rPr lang="en-US" smtClean="0"/>
-              <a:t>9/22/26</a:t>
+              <a:t>9/23/26</a:t>
             </a:fld>
             <a:endParaRPr lang="en-US"/>
           </a:p>
@@ -2912,7 +2917,7 @@
           <a:p>
             <a:fld id="{17B77B90-EC0E-BC4E-91B7-09E65585EB38}" type="datetimeFigureOut">
               <a:rPr lang="en-US" smtClean="0"/>
-              <a:t>9/22/26</a:t>
+              <a:t>9/23/26</a:t>
             </a:fld>
             <a:endParaRPr lang="en-US"/>
           </a:p>

</xml_diff>

<commit_message>
Checkpoint pending work before docs-sync run
Includes: ConnectYourAgent OTel/tracing-stack section, business-case
deck ROI metric updates, External Interest tracker updates, agent
cost/usage PRD + prototype, kb.py FAQ path fix, Sept 24 meeting notes,
and gitignore entries for email-automation CSVs.

Co-Authored-By: Claude Sonnet 5 <noreply@anthropic.com>
</commit_message>
<xml_diff>
--- a/docs/decks/business-case-deck/output/AgentScore-Business-Case-Native.pptx
+++ b/docs/decks/business-case-deck/output/AgentScore-Business-Case-Native.pptx
@@ -267,7 +267,7 @@
           <a:p>
             <a:fld id="{17B77B90-EC0E-BC4E-91B7-09E65585EB38}" type="datetimeFigureOut">
               <a:rPr lang="en-US" smtClean="0"/>
-              <a:t>9/23/26</a:t>
+              <a:t>9/24/26</a:t>
             </a:fld>
             <a:endParaRPr lang="en-US"/>
           </a:p>
@@ -465,7 +465,7 @@
           <a:p>
             <a:fld id="{17B77B90-EC0E-BC4E-91B7-09E65585EB38}" type="datetimeFigureOut">
               <a:rPr lang="en-US" smtClean="0"/>
-              <a:t>9/23/26</a:t>
+              <a:t>9/24/26</a:t>
             </a:fld>
             <a:endParaRPr lang="en-US"/>
           </a:p>
@@ -673,7 +673,7 @@
           <a:p>
             <a:fld id="{17B77B90-EC0E-BC4E-91B7-09E65585EB38}" type="datetimeFigureOut">
               <a:rPr lang="en-US" smtClean="0"/>
-              <a:t>9/23/26</a:t>
+              <a:t>9/24/26</a:t>
             </a:fld>
             <a:endParaRPr lang="en-US"/>
           </a:p>
@@ -871,7 +871,7 @@
           <a:p>
             <a:fld id="{17B77B90-EC0E-BC4E-91B7-09E65585EB38}" type="datetimeFigureOut">
               <a:rPr lang="en-US" smtClean="0"/>
-              <a:t>9/23/26</a:t>
+              <a:t>9/24/26</a:t>
             </a:fld>
             <a:endParaRPr lang="en-US"/>
           </a:p>
@@ -1146,7 +1146,7 @@
           <a:p>
             <a:fld id="{17B77B90-EC0E-BC4E-91B7-09E65585EB38}" type="datetimeFigureOut">
               <a:rPr lang="en-US" smtClean="0"/>
-              <a:t>9/23/26</a:t>
+              <a:t>9/24/26</a:t>
             </a:fld>
             <a:endParaRPr lang="en-US"/>
           </a:p>
@@ -1411,7 +1411,7 @@
           <a:p>
             <a:fld id="{17B77B90-EC0E-BC4E-91B7-09E65585EB38}" type="datetimeFigureOut">
               <a:rPr lang="en-US" smtClean="0"/>
-              <a:t>9/23/26</a:t>
+              <a:t>9/24/26</a:t>
             </a:fld>
             <a:endParaRPr lang="en-US"/>
           </a:p>
@@ -1823,7 +1823,7 @@
           <a:p>
             <a:fld id="{17B77B90-EC0E-BC4E-91B7-09E65585EB38}" type="datetimeFigureOut">
               <a:rPr lang="en-US" smtClean="0"/>
-              <a:t>9/23/26</a:t>
+              <a:t>9/24/26</a:t>
             </a:fld>
             <a:endParaRPr lang="en-US"/>
           </a:p>
@@ -1964,7 +1964,7 @@
           <a:p>
             <a:fld id="{17B77B90-EC0E-BC4E-91B7-09E65585EB38}" type="datetimeFigureOut">
               <a:rPr lang="en-US" smtClean="0"/>
-              <a:t>9/23/26</a:t>
+              <a:t>9/24/26</a:t>
             </a:fld>
             <a:endParaRPr lang="en-US"/>
           </a:p>
@@ -2077,7 +2077,7 @@
           <a:p>
             <a:fld id="{17B77B90-EC0E-BC4E-91B7-09E65585EB38}" type="datetimeFigureOut">
               <a:rPr lang="en-US" smtClean="0"/>
-              <a:t>9/23/26</a:t>
+              <a:t>9/24/26</a:t>
             </a:fld>
             <a:endParaRPr lang="en-US"/>
           </a:p>
@@ -2388,7 +2388,7 @@
           <a:p>
             <a:fld id="{17B77B90-EC0E-BC4E-91B7-09E65585EB38}" type="datetimeFigureOut">
               <a:rPr lang="en-US" smtClean="0"/>
-              <a:t>9/23/26</a:t>
+              <a:t>9/24/26</a:t>
             </a:fld>
             <a:endParaRPr lang="en-US"/>
           </a:p>
@@ -2676,7 +2676,7 @@
           <a:p>
             <a:fld id="{17B77B90-EC0E-BC4E-91B7-09E65585EB38}" type="datetimeFigureOut">
               <a:rPr lang="en-US" smtClean="0"/>
-              <a:t>9/23/26</a:t>
+              <a:t>9/24/26</a:t>
             </a:fld>
             <a:endParaRPr lang="en-US"/>
           </a:p>
@@ -2917,7 +2917,7 @@
           <a:p>
             <a:fld id="{17B77B90-EC0E-BC4E-91B7-09E65585EB38}" type="datetimeFigureOut">
               <a:rPr lang="en-US" smtClean="0"/>
-              <a:t>9/23/26</a:t>
+              <a:t>9/24/26</a:t>
             </a:fld>
             <a:endParaRPr lang="en-US"/>
           </a:p>
@@ -3484,7 +3484,7 @@
         </p:nvSpPr>
         <p:spPr>
           <a:xfrm>
-            <a:off x="5613400" y="4419600"/>
+            <a:off x="5378116" y="4180576"/>
             <a:ext cx="101600" cy="101600"/>
           </a:xfrm>
           <a:prstGeom prst="ellipse">
@@ -3545,7 +3545,7 @@
         </p:nvSpPr>
         <p:spPr>
           <a:xfrm>
-            <a:off x="5816600" y="4343400"/>
+            <a:off x="5479716" y="4107765"/>
             <a:ext cx="2540000" cy="261610"/>
           </a:xfrm>
           <a:prstGeom prst="rect">
@@ -3560,7 +3560,7 @@
           <a:lstStyle/>
           <a:p>
             <a:r>
-              <a:rPr lang="en-US" sz="1100" b="1">
+              <a:rPr lang="en-US" sz="1100" b="1" dirty="0">
                 <a:solidFill>
                   <a:srgbClr val="C7D2E3"/>
                 </a:solidFill>
@@ -4686,7 +4686,7 @@
         <p:spPr>
           <a:xfrm>
             <a:off x="4470400" y="4749799"/>
-            <a:ext cx="2946400" cy="1041400"/>
+            <a:ext cx="2946400" cy="738664"/>
           </a:xfrm>
           <a:prstGeom prst="rect">
             <a:avLst/>
@@ -4700,12 +4700,28 @@
           <a:lstStyle/>
           <a:p>
             <a:r>
-              <a:rPr lang="en-US" sz="1050">
+              <a:rPr lang="en-US" sz="1050" dirty="0">
                 <a:solidFill>
                   <a:srgbClr val="A9B8D1"/>
                 </a:solidFill>
               </a:rPr>
-              <a:t>Of agentic AI projects Gartner projects will be canceled by end of 2027 — the exact failure mode AgentScore exists to prevent</a:t>
+              <a:t>Of agentic AI projects Gartner projects will be canceled by end of 2027 due to cost, unclear value, and inadequate risk controls -  the exact failure mode </a:t>
+            </a:r>
+            <a:r>
+              <a:rPr lang="en-US" sz="1050" dirty="0" err="1">
+                <a:solidFill>
+                  <a:srgbClr val="A9B8D1"/>
+                </a:solidFill>
+              </a:rPr>
+              <a:t>AgentScore</a:t>
+            </a:r>
+            <a:r>
+              <a:rPr lang="en-US" sz="1050" dirty="0">
+                <a:solidFill>
+                  <a:srgbClr val="A9B8D1"/>
+                </a:solidFill>
+              </a:rPr>
+              <a:t> exists to prevent</a:t>
             </a:r>
           </a:p>
         </p:txBody>
@@ -5023,7 +5039,7 @@
                   <a:srgbClr val="FFFFFF"/>
                 </a:solidFill>
               </a:rPr>
-              <a:t>7</a:t>
+              <a:t>9</a:t>
             </a:r>
           </a:p>
         </p:txBody>
@@ -12261,8 +12277,8 @@
         </p:nvSpPr>
         <p:spPr>
           <a:xfrm>
-            <a:off x="5645150" y="5421268"/>
-            <a:ext cx="5689600" cy="600164"/>
+            <a:off x="5638800" y="5370239"/>
+            <a:ext cx="5689600" cy="769441"/>
           </a:xfrm>
           <a:prstGeom prst="rect">
             <a:avLst/>
@@ -12281,7 +12297,7 @@
                   <a:srgbClr val="C7D2E3"/>
                 </a:solidFill>
               </a:rPr>
-              <a:t>The billing model is already proven by the category — eval-first competitors meter scoring runs at a premium, separate from ingestion. A subscription only has to prevent a fraction of one incident to pay for itself many times over.</a:t>
+              <a:t>The billing model is already proven by the category — eval-first competitors meter scoring runs at a premium, separate from ingestion. A subscription only has to prevent a fraction of one incident, reclaim a sliver of wasted token spend, or claw back a few hours of eval-authoring time to pay for itself many times over.</a:t>
             </a:r>
           </a:p>
         </p:txBody>
@@ -12431,7 +12447,7 @@
           <a:lstStyle/>
           <a:p>
             <a:r>
-              <a:rPr lang="en-US" sz="1400" i="1">
+              <a:rPr lang="en-US" sz="1400" i="1" dirty="0">
                 <a:solidFill>
                   <a:srgbClr val="C7D2E3"/>
                 </a:solidFill>
@@ -12610,12 +12626,12 @@
           <a:lstStyle/>
           <a:p>
             <a:r>
-              <a:rPr lang="en-US" sz="1200" b="1">
+              <a:rPr lang="en-US" sz="1200" b="1" dirty="0">
                 <a:solidFill>
                   <a:srgbClr val="38BDF8"/>
                 </a:solidFill>
               </a:rPr>
-              <a:t>INCIDENT-INVESTIGATION TIME SAVED</a:t>
+              <a:t>TIME SAVED ON EVALS</a:t>
             </a:r>
           </a:p>
         </p:txBody>
@@ -12712,12 +12728,28 @@
           <a:lstStyle/>
           <a:p>
             <a:r>
-              <a:rPr lang="en-US" sz="1600" b="1">
+              <a:rPr lang="en-US" sz="1600" b="1" dirty="0">
                 <a:solidFill>
                   <a:srgbClr val="FFFFFF"/>
                 </a:solidFill>
               </a:rPr>
-              <a:t>??? hrs/wk</a:t>
+              <a:t>??? </a:t>
+            </a:r>
+            <a:r>
+              <a:rPr lang="en-US" sz="1600" b="1" dirty="0" err="1">
+                <a:solidFill>
+                  <a:srgbClr val="FFFFFF"/>
+                </a:solidFill>
+              </a:rPr>
+              <a:t>hrs</a:t>
+            </a:r>
+            <a:r>
+              <a:rPr lang="en-US" sz="1600" b="1" dirty="0">
+                <a:solidFill>
+                  <a:srgbClr val="FFFFFF"/>
+                </a:solidFill>
+              </a:rPr>
+              <a:t>/agent/week</a:t>
             </a:r>
           </a:p>
         </p:txBody>
@@ -12751,12 +12783,12 @@
           <a:lstStyle/>
           <a:p>
             <a:r>
-              <a:rPr lang="en-US" sz="900">
+              <a:rPr lang="en-US" sz="900" dirty="0">
                 <a:solidFill>
                   <a:srgbClr val="A9B8D1"/>
                 </a:solidFill>
               </a:rPr>
-              <a:t>Baseline unmeasured internally — externally reported ~4.3 hrs/wk</a:t>
+              <a:t>Baseline unmeasured — no pilot customer has tracked eval-authoring time yet</a:t>
             </a:r>
           </a:p>
         </p:txBody>
@@ -12853,12 +12885,12 @@
           <a:lstStyle/>
           <a:p>
             <a:r>
-              <a:rPr lang="en-US" sz="1600" b="1">
+              <a:rPr lang="en-US" sz="1600" b="1" dirty="0">
                 <a:solidFill>
                   <a:srgbClr val="FFFFFF"/>
                 </a:solidFill>
               </a:rPr>
-              <a:t>25%</a:t>
+              <a:t>40%</a:t>
             </a:r>
           </a:p>
         </p:txBody>
@@ -12892,12 +12924,28 @@
           <a:lstStyle/>
           <a:p>
             <a:r>
-              <a:rPr lang="en-US" sz="900">
+              <a:rPr lang="en-US" sz="900" dirty="0">
                 <a:solidFill>
                   <a:srgbClr val="A9B8D1"/>
                 </a:solidFill>
               </a:rPr>
-              <a:t>Hypothesis: incident-investigation time drops if root-cause attribution works as designed</a:t>
+              <a:t>Hypothesis: time saved per agent per week if </a:t>
+            </a:r>
+            <a:r>
+              <a:rPr lang="en-US" sz="900" dirty="0" err="1">
+                <a:solidFill>
+                  <a:srgbClr val="A9B8D1"/>
+                </a:solidFill>
+              </a:rPr>
+              <a:t>AgentScore</a:t>
+            </a:r>
+            <a:r>
+              <a:rPr lang="en-US" sz="900" dirty="0">
+                <a:solidFill>
+                  <a:srgbClr val="A9B8D1"/>
+                </a:solidFill>
+              </a:rPr>
+              <a:t> auto-generates evals vs. manual authoring</a:t>
             </a:r>
           </a:p>
         </p:txBody>
@@ -12994,12 +13042,12 @@
           <a:lstStyle/>
           <a:p>
             <a:r>
-              <a:rPr lang="en-US" sz="1600" b="1">
+              <a:rPr lang="en-US" sz="1600" b="1" dirty="0">
                 <a:solidFill>
                   <a:srgbClr val="FFFFFF"/>
                 </a:solidFill>
               </a:rPr>
-              <a:t>$3.5K/yr</a:t>
+              <a:t>$???/yr</a:t>
             </a:r>
           </a:p>
         </p:txBody>
@@ -13072,12 +13120,12 @@
           <a:lstStyle/>
           <a:p>
             <a:r>
-              <a:rPr lang="en-US" sz="1200" b="1">
+              <a:rPr lang="en-US" sz="1200" b="1" dirty="0">
                 <a:solidFill>
                   <a:srgbClr val="38BDF8"/>
                 </a:solidFill>
               </a:rPr>
-              <a:t>AUDIT-EVIDENCE TURNAROUND TIME</a:t>
+              <a:t>% OF TOKEN SPEND REDUCTION</a:t>
             </a:r>
           </a:p>
         </p:txBody>
@@ -13174,12 +13222,12 @@
           <a:lstStyle/>
           <a:p>
             <a:r>
-              <a:rPr lang="en-US" sz="1600" b="1">
+              <a:rPr lang="en-US" sz="1600" b="1" dirty="0">
                 <a:solidFill>
                   <a:srgbClr val="FFFFFF"/>
                 </a:solidFill>
               </a:rPr>
-              <a:t>??? days</a:t>
+              <a:t>??? </a:t>
             </a:r>
           </a:p>
         </p:txBody>
@@ -13199,7 +13247,7 @@
         <p:spPr>
           <a:xfrm>
             <a:off x="787400" y="3860800"/>
-            <a:ext cx="3162300" cy="369332"/>
+            <a:ext cx="3162300" cy="230832"/>
           </a:xfrm>
           <a:prstGeom prst="rect">
             <a:avLst/>
@@ -13213,12 +13261,12 @@
           <a:lstStyle/>
           <a:p>
             <a:r>
-              <a:rPr lang="en-US" sz="900">
+              <a:rPr lang="en-US" sz="900" dirty="0">
                 <a:solidFill>
                   <a:srgbClr val="A9B8D1"/>
                 </a:solidFill>
               </a:rPr>
-              <a:t>Unmeasured, ad hoc today at every account (Wolters Kluwer, Freddie Mac)</a:t>
+              <a:t>No real customer token bill to benchmark against yet</a:t>
             </a:r>
           </a:p>
         </p:txBody>
@@ -13315,12 +13363,12 @@
           <a:lstStyle/>
           <a:p>
             <a:r>
-              <a:rPr lang="en-US" sz="1600" b="1">
+              <a:rPr lang="en-US" sz="1600" b="1" dirty="0">
                 <a:solidFill>
                   <a:srgbClr val="FFFFFF"/>
                 </a:solidFill>
               </a:rPr>
-              <a:t>Ad Hoc → SLA</a:t>
+              <a:t>40–60%</a:t>
             </a:r>
           </a:p>
         </p:txBody>
@@ -13339,8 +13387,8 @@
         </p:nvSpPr>
         <p:spPr>
           <a:xfrm>
-            <a:off x="4508500" y="3860800"/>
-            <a:ext cx="3162300" cy="369332"/>
+            <a:off x="4508500" y="3775244"/>
+            <a:ext cx="3162300" cy="507831"/>
           </a:xfrm>
           <a:prstGeom prst="rect">
             <a:avLst/>
@@ -13354,12 +13402,28 @@
           <a:lstStyle/>
           <a:p>
             <a:r>
-              <a:rPr lang="en-US" sz="900">
+              <a:rPr lang="en-US" sz="900" dirty="0">
                 <a:solidFill>
                   <a:srgbClr val="A9B8D1"/>
                 </a:solidFill>
               </a:rPr>
-              <a:t>Hypothesis: the tiered evidence model turns this into a reportable SLA</a:t>
+              <a:t>Gartner: agentic token spend that contributes nothing to the answer. Hypothesis: </a:t>
+            </a:r>
+            <a:r>
+              <a:rPr lang="en-US" sz="900" dirty="0" err="1">
+                <a:solidFill>
+                  <a:srgbClr val="A9B8D1"/>
+                </a:solidFill>
+              </a:rPr>
+              <a:t>AgentScore</a:t>
+            </a:r>
+            <a:r>
+              <a:rPr lang="en-US" sz="900" dirty="0">
+                <a:solidFill>
+                  <a:srgbClr val="A9B8D1"/>
+                </a:solidFill>
+              </a:rPr>
+              <a:t> can flag and reduce this share.</a:t>
             </a:r>
           </a:p>
         </p:txBody>
@@ -13456,12 +13520,12 @@
           <a:lstStyle/>
           <a:p>
             <a:r>
-              <a:rPr lang="en-US" sz="1600" b="1">
+              <a:rPr lang="en-US" sz="1600" b="1" dirty="0">
                 <a:solidFill>
                   <a:srgbClr val="FFFFFF"/>
                 </a:solidFill>
               </a:rPr>
-              <a:t>Before vs. After</a:t>
+              <a:t>Bill vs. flag</a:t>
             </a:r>
           </a:p>
         </p:txBody>
@@ -13480,8 +13544,8 @@
         </p:nvSpPr>
         <p:spPr>
           <a:xfrm>
-            <a:off x="8229600" y="3860800"/>
-            <a:ext cx="3162300" cy="369332"/>
+            <a:off x="8229600" y="3743710"/>
+            <a:ext cx="3162300" cy="507831"/>
           </a:xfrm>
           <a:prstGeom prst="rect">
             <a:avLst/>
@@ -13495,12 +13559,44 @@
           <a:lstStyle/>
           <a:p>
             <a:r>
-              <a:rPr lang="en-US" sz="900">
+              <a:rPr lang="en-US" sz="900" dirty="0">
                 <a:solidFill>
                   <a:srgbClr val="A9B8D1"/>
                 </a:solidFill>
               </a:rPr>
-              <a:t>Time-to-evidence at a pilot account, measured before and after AgentScore</a:t>
+              <a:t>Compare </a:t>
+            </a:r>
+            <a:r>
+              <a:rPr lang="en-US" sz="900" dirty="0" err="1">
+                <a:solidFill>
+                  <a:srgbClr val="A9B8D1"/>
+                </a:solidFill>
+              </a:rPr>
+              <a:t>AgentScore</a:t>
+            </a:r>
+            <a:r>
+              <a:rPr lang="en-US" sz="900" dirty="0">
+                <a:solidFill>
+                  <a:srgbClr val="A9B8D1"/>
+                </a:solidFill>
+              </a:rPr>
+              <a:t>-flagged low-value spend against a pilot customer's actual token bill, before vs. after </a:t>
+            </a:r>
+            <a:r>
+              <a:rPr lang="en-US" sz="900" dirty="0" err="1">
+                <a:solidFill>
+                  <a:srgbClr val="A9B8D1"/>
+                </a:solidFill>
+              </a:rPr>
+              <a:t>AgentScore</a:t>
+            </a:r>
+            <a:r>
+              <a:rPr lang="en-US" sz="900" dirty="0">
+                <a:solidFill>
+                  <a:srgbClr val="A9B8D1"/>
+                </a:solidFill>
+              </a:rPr>
+              <a:t>, net of usage growth.</a:t>
             </a:r>
           </a:p>
         </p:txBody>
@@ -13534,12 +13630,12 @@
           <a:lstStyle/>
           <a:p>
             <a:r>
-              <a:rPr lang="en-US" sz="1200" b="1">
+              <a:rPr lang="en-US" sz="1200" b="1" dirty="0">
                 <a:solidFill>
                   <a:srgbClr val="38BDF8"/>
                 </a:solidFill>
               </a:rPr>
-              <a:t>% OF TOKEN SPEND RECOVERED AS WASTE</a:t>
+              <a:t>REDUCTION IN AI-RELATED INCIDENTS</a:t>
             </a:r>
           </a:p>
         </p:txBody>
@@ -13636,12 +13732,12 @@
           <a:lstStyle/>
           <a:p>
             <a:r>
-              <a:rPr lang="en-US" sz="1600" b="1">
+              <a:rPr lang="en-US" sz="1600" b="1" dirty="0">
                 <a:solidFill>
                   <a:srgbClr val="FFFFFF"/>
                 </a:solidFill>
               </a:rPr>
-              <a:t>??? %</a:t>
+              <a:t>??? </a:t>
             </a:r>
           </a:p>
         </p:txBody>
@@ -13661,7 +13757,7 @@
         <p:spPr>
           <a:xfrm>
             <a:off x="787400" y="5257800"/>
-            <a:ext cx="3162300" cy="230832"/>
+            <a:ext cx="3162300" cy="369332"/>
           </a:xfrm>
           <a:prstGeom prst="rect">
             <a:avLst/>
@@ -13675,12 +13771,12 @@
           <a:lstStyle/>
           <a:p>
             <a:r>
-              <a:rPr lang="en-US" sz="900">
+              <a:rPr lang="en-US" sz="900" dirty="0">
                 <a:solidFill>
                   <a:srgbClr val="A9B8D1"/>
                 </a:solidFill>
               </a:rPr>
-              <a:t>No real customer token bill to benchmark against yet</a:t>
+              <a:t>Incident counts tied to agent behavior (bad outputs, safety violations, compliance failures) </a:t>
             </a:r>
           </a:p>
         </p:txBody>
@@ -13777,12 +13873,12 @@
           <a:lstStyle/>
           <a:p>
             <a:r>
-              <a:rPr lang="en-US" sz="1600" b="1">
+              <a:rPr lang="en-US" sz="1600" b="1" dirty="0">
                 <a:solidFill>
                   <a:srgbClr val="FFFFFF"/>
                 </a:solidFill>
               </a:rPr>
-              <a:t>40–60%</a:t>
+              <a:t>20 % </a:t>
             </a:r>
           </a:p>
         </p:txBody>
@@ -13816,12 +13912,12 @@
           <a:lstStyle/>
           <a:p>
             <a:r>
-              <a:rPr lang="en-US" sz="900">
+              <a:rPr lang="en-US" sz="900" dirty="0">
                 <a:solidFill>
                   <a:srgbClr val="A9B8D1"/>
                 </a:solidFill>
               </a:rPr>
-              <a:t>Gartner: agentic token spend that contributes nothing to the answer</a:t>
+              <a:t>Hypothesis: continuous scoring catches regressions before they reach production, reducing incident volume.</a:t>
             </a:r>
           </a:p>
         </p:txBody>
@@ -13918,12 +14014,12 @@
           <a:lstStyle/>
           <a:p>
             <a:r>
-              <a:rPr lang="en-US" sz="1600" b="1">
+              <a:rPr lang="en-US" sz="1600" b="1" dirty="0">
                 <a:solidFill>
                   <a:srgbClr val="FFFFFF"/>
                 </a:solidFill>
               </a:rPr>
-              <a:t>Bill vs. Flag</a:t>
+              <a:t>Before vs. after </a:t>
             </a:r>
           </a:p>
         </p:txBody>
@@ -13957,12 +14053,28 @@
           <a:lstStyle/>
           <a:p>
             <a:r>
-              <a:rPr lang="en-US" sz="900">
+              <a:rPr lang="en-US" sz="900" dirty="0">
                 <a:solidFill>
                   <a:srgbClr val="A9B8D1"/>
                 </a:solidFill>
               </a:rPr>
-              <a:t>AgentScore-flagged low-value spend vs. a pilot customer's actual bill</a:t>
+              <a:t>Compare AI-related incident counts at a pilot account before vs. after </a:t>
+            </a:r>
+            <a:r>
+              <a:rPr lang="en-US" sz="900" dirty="0" err="1">
+                <a:solidFill>
+                  <a:srgbClr val="A9B8D1"/>
+                </a:solidFill>
+              </a:rPr>
+              <a:t>AgentScore</a:t>
+            </a:r>
+            <a:r>
+              <a:rPr lang="en-US" sz="900" dirty="0">
+                <a:solidFill>
+                  <a:srgbClr val="A9B8D1"/>
+                </a:solidFill>
+              </a:rPr>
+              <a:t>, over a matched time window.</a:t>
             </a:r>
           </a:p>
         </p:txBody>
@@ -14041,7 +14153,7 @@
         </p:nvSpPr>
         <p:spPr>
           <a:xfrm>
-            <a:off x="838200" y="5943600"/>
+            <a:off x="858119" y="5994442"/>
             <a:ext cx="10515600" cy="253916"/>
           </a:xfrm>
           <a:prstGeom prst="rect">
@@ -14056,7 +14168,7 @@
           <a:lstStyle/>
           <a:p>
             <a:r>
-              <a:rPr lang="en-US" sz="1050" b="1">
+              <a:rPr lang="en-US" sz="1050" b="1" dirty="0">
                 <a:solidFill>
                   <a:srgbClr val="FFFFFF"/>
                 </a:solidFill>

</xml_diff>